<commit_message>
Hinzufügen Scotts Teil für Technikforum und .tex Output Folder wird nun ignoriert in git
</commit_message>
<xml_diff>
--- a/doc/Technikforum/Plakat_Forum.pptx
+++ b/doc/Technikforum/Plakat_Forum.pptx
@@ -107,6 +107,11 @@
       </a:defRPr>
     </a:lvl9pPr>
   </p:defaultTextStyle>
+  <p:extLst>
+    <p:ext uri="{EFAFB233-063F-42B5-8137-9DF3F51BA10A}">
+      <p15:sldGuideLst xmlns:p15="http://schemas.microsoft.com/office/powerpoint/2012/main"/>
+    </p:ext>
+  </p:extLst>
 </p:presentation>
 </file>
 
@@ -237,7 +242,7 @@
           <a:p>
             <a:fld id="{61A61C3E-B578-482D-ADF4-0DD2B122CA35}" type="datetimeFigureOut">
               <a:rPr lang="de-DE" smtClean="0"/>
-              <a:t>18.05.2026</a:t>
+              <a:t>19.05.2026</a:t>
             </a:fld>
             <a:endParaRPr lang="de-DE"/>
           </a:p>
@@ -635,7 +640,7 @@
           <a:p>
             <a:fld id="{7A967564-6120-49BA-AFB2-40F93D1AEBD4}" type="datetimeFigureOut">
               <a:rPr lang="de-DE" smtClean="0"/>
-              <a:t>18.05.2026</a:t>
+              <a:t>19.05.2026</a:t>
             </a:fld>
             <a:endParaRPr lang="de-DE"/>
           </a:p>
@@ -805,7 +810,7 @@
           <a:p>
             <a:fld id="{7A967564-6120-49BA-AFB2-40F93D1AEBD4}" type="datetimeFigureOut">
               <a:rPr lang="de-DE" smtClean="0"/>
-              <a:t>18.05.2026</a:t>
+              <a:t>19.05.2026</a:t>
             </a:fld>
             <a:endParaRPr lang="de-DE"/>
           </a:p>
@@ -985,7 +990,7 @@
           <a:p>
             <a:fld id="{7A967564-6120-49BA-AFB2-40F93D1AEBD4}" type="datetimeFigureOut">
               <a:rPr lang="de-DE" smtClean="0"/>
-              <a:t>18.05.2026</a:t>
+              <a:t>19.05.2026</a:t>
             </a:fld>
             <a:endParaRPr lang="de-DE"/>
           </a:p>
@@ -1155,7 +1160,7 @@
           <a:p>
             <a:fld id="{7A967564-6120-49BA-AFB2-40F93D1AEBD4}" type="datetimeFigureOut">
               <a:rPr lang="de-DE" smtClean="0"/>
-              <a:t>18.05.2026</a:t>
+              <a:t>19.05.2026</a:t>
             </a:fld>
             <a:endParaRPr lang="de-DE"/>
           </a:p>
@@ -1401,7 +1406,7 @@
           <a:p>
             <a:fld id="{7A967564-6120-49BA-AFB2-40F93D1AEBD4}" type="datetimeFigureOut">
               <a:rPr lang="de-DE" smtClean="0"/>
-              <a:t>18.05.2026</a:t>
+              <a:t>19.05.2026</a:t>
             </a:fld>
             <a:endParaRPr lang="de-DE"/>
           </a:p>
@@ -1633,7 +1638,7 @@
           <a:p>
             <a:fld id="{7A967564-6120-49BA-AFB2-40F93D1AEBD4}" type="datetimeFigureOut">
               <a:rPr lang="de-DE" smtClean="0"/>
-              <a:t>18.05.2026</a:t>
+              <a:t>19.05.2026</a:t>
             </a:fld>
             <a:endParaRPr lang="de-DE"/>
           </a:p>
@@ -2000,7 +2005,7 @@
           <a:p>
             <a:fld id="{7A967564-6120-49BA-AFB2-40F93D1AEBD4}" type="datetimeFigureOut">
               <a:rPr lang="de-DE" smtClean="0"/>
-              <a:t>18.05.2026</a:t>
+              <a:t>19.05.2026</a:t>
             </a:fld>
             <a:endParaRPr lang="de-DE"/>
           </a:p>
@@ -2118,7 +2123,7 @@
           <a:p>
             <a:fld id="{7A967564-6120-49BA-AFB2-40F93D1AEBD4}" type="datetimeFigureOut">
               <a:rPr lang="de-DE" smtClean="0"/>
-              <a:t>18.05.2026</a:t>
+              <a:t>19.05.2026</a:t>
             </a:fld>
             <a:endParaRPr lang="de-DE"/>
           </a:p>
@@ -2213,7 +2218,7 @@
           <a:p>
             <a:fld id="{7A967564-6120-49BA-AFB2-40F93D1AEBD4}" type="datetimeFigureOut">
               <a:rPr lang="de-DE" smtClean="0"/>
-              <a:t>18.05.2026</a:t>
+              <a:t>19.05.2026</a:t>
             </a:fld>
             <a:endParaRPr lang="de-DE"/>
           </a:p>
@@ -2490,7 +2495,7 @@
           <a:p>
             <a:fld id="{7A967564-6120-49BA-AFB2-40F93D1AEBD4}" type="datetimeFigureOut">
               <a:rPr lang="de-DE" smtClean="0"/>
-              <a:t>18.05.2026</a:t>
+              <a:t>19.05.2026</a:t>
             </a:fld>
             <a:endParaRPr lang="de-DE"/>
           </a:p>
@@ -2747,7 +2752,7 @@
           <a:p>
             <a:fld id="{7A967564-6120-49BA-AFB2-40F93D1AEBD4}" type="datetimeFigureOut">
               <a:rPr lang="de-DE" smtClean="0"/>
-              <a:t>18.05.2026</a:t>
+              <a:t>19.05.2026</a:t>
             </a:fld>
             <a:endParaRPr lang="de-DE"/>
           </a:p>
@@ -2960,7 +2965,7 @@
           <a:p>
             <a:fld id="{7A967564-6120-49BA-AFB2-40F93D1AEBD4}" type="datetimeFigureOut">
               <a:rPr lang="de-DE" smtClean="0"/>
-              <a:t>18.05.2026</a:t>
+              <a:t>19.05.2026</a:t>
             </a:fld>
             <a:endParaRPr lang="de-DE"/>
           </a:p>
@@ -3865,12 +3870,8 @@
           <a:lstStyle/>
           <a:p>
             <a:r>
-              <a:rPr lang="de-DE" sz="2260" b="1" dirty="0" err="1"/>
-              <a:t>BézierkurveParametrische</a:t>
-            </a:r>
-            <a:r>
               <a:rPr lang="de-DE" sz="2260" b="1" dirty="0"/>
-              <a:t> </a:t>
+              <a:t>Bézierkurve Parametrische </a:t>
             </a:r>
           </a:p>
           <a:p>
@@ -4398,6 +4399,436 @@
           </a:p>
         </p:txBody>
       </p:sp>
+      <p:sp>
+        <p:nvSpPr>
+          <p:cNvPr id="6" name="Textfeld 5">
+            <a:extLst>
+              <a:ext uri="{FF2B5EF4-FFF2-40B4-BE49-F238E27FC236}">
+                <a16:creationId xmlns:a16="http://schemas.microsoft.com/office/drawing/2014/main" id="{ED171B0D-BEA3-3447-F325-D6980DEC0ECF}"/>
+              </a:ext>
+            </a:extLst>
+          </p:cNvPr>
+          <p:cNvSpPr txBox="1"/>
+          <p:nvPr/>
+        </p:nvSpPr>
+        <p:spPr>
+          <a:xfrm>
+            <a:off x="10420247" y="3067986"/>
+            <a:ext cx="10773506" cy="2179058"/>
+          </a:xfrm>
+          <a:prstGeom prst="rect">
+            <a:avLst/>
+          </a:prstGeom>
+          <a:noFill/>
+        </p:spPr>
+        <p:txBody>
+          <a:bodyPr wrap="square">
+            <a:spAutoFit/>
+          </a:bodyPr>
+          <a:lstStyle/>
+          <a:p>
+            <a:r>
+              <a:rPr lang="de-DE" sz="2260" b="1" dirty="0"/>
+              <a:t>System-Optimierung</a:t>
+            </a:r>
+          </a:p>
+          <a:p>
+            <a:pPr marL="342900" indent="-342900">
+              <a:buFont typeface="Arial" panose="020B0604020202020204" pitchFamily="34" charset="0"/>
+              <a:buChar char="•"/>
+            </a:pPr>
+            <a:r>
+              <a:rPr lang="de-DE" sz="2260" dirty="0"/>
+              <a:t>Wechsel von Ubuntu Desktop zu Ubuntu Server</a:t>
+            </a:r>
+          </a:p>
+          <a:p>
+            <a:pPr marL="342900" indent="-342900">
+              <a:buFont typeface="Arial" panose="020B0604020202020204" pitchFamily="34" charset="0"/>
+              <a:buChar char="•"/>
+            </a:pPr>
+            <a:r>
+              <a:rPr lang="de-DE" sz="2260" dirty="0"/>
+              <a:t>Speicherauslastung (16GB SSD): 100% -&gt; ~25%</a:t>
+            </a:r>
+          </a:p>
+          <a:p>
+            <a:pPr marL="342900" indent="-342900">
+              <a:buFont typeface="Arial" panose="020B0604020202020204" pitchFamily="34" charset="0"/>
+              <a:buChar char="•"/>
+            </a:pPr>
+            <a:r>
+              <a:rPr lang="de-DE" sz="2260" dirty="0"/>
+              <a:t>CPU-Auslastung: ~90%  (ohne aktivem LiDAR) -&gt; ~50% (mit aktivem LiDAR)</a:t>
+            </a:r>
+          </a:p>
+          <a:p>
+            <a:pPr marL="342900" indent="-342900">
+              <a:buFont typeface="Arial" panose="020B0604020202020204" pitchFamily="34" charset="0"/>
+              <a:buChar char="•"/>
+            </a:pPr>
+            <a:r>
+              <a:rPr lang="de-DE" sz="2260" dirty="0"/>
+              <a:t>Durch das Entfernen der UI des Raspberry </a:t>
+            </a:r>
+            <a:r>
+              <a:rPr lang="de-DE" sz="2260" dirty="0" err="1"/>
+              <a:t>Pi‘s</a:t>
+            </a:r>
+            <a:r>
+              <a:rPr lang="de-DE" sz="2260" dirty="0"/>
+              <a:t> werden dringend benötigte Ressourcen frei</a:t>
+            </a:r>
+          </a:p>
+        </p:txBody>
+      </p:sp>
+      <p:sp>
+        <p:nvSpPr>
+          <p:cNvPr id="13" name="Textfeld 12">
+            <a:extLst>
+              <a:ext uri="{FF2B5EF4-FFF2-40B4-BE49-F238E27FC236}">
+                <a16:creationId xmlns:a16="http://schemas.microsoft.com/office/drawing/2014/main" id="{E9E4120F-2570-6A77-8123-F0466D59CFD1}"/>
+              </a:ext>
+            </a:extLst>
+          </p:cNvPr>
+          <p:cNvSpPr txBox="1"/>
+          <p:nvPr/>
+        </p:nvSpPr>
+        <p:spPr>
+          <a:xfrm>
+            <a:off x="10420247" y="5689973"/>
+            <a:ext cx="10773506" cy="1831271"/>
+          </a:xfrm>
+          <a:prstGeom prst="rect">
+            <a:avLst/>
+          </a:prstGeom>
+          <a:noFill/>
+        </p:spPr>
+        <p:txBody>
+          <a:bodyPr wrap="square">
+            <a:spAutoFit/>
+          </a:bodyPr>
+          <a:lstStyle/>
+          <a:p>
+            <a:r>
+              <a:rPr lang="de-DE" sz="2260" b="1" dirty="0"/>
+              <a:t>Software &amp; Architektur</a:t>
+            </a:r>
+          </a:p>
+          <a:p>
+            <a:pPr marL="342900" indent="-342900">
+              <a:buFont typeface="Arial" panose="020B0604020202020204" pitchFamily="34" charset="0"/>
+              <a:buChar char="•"/>
+            </a:pPr>
+            <a:r>
+              <a:rPr lang="de-DE" sz="2260" dirty="0"/>
+              <a:t>In Ubuntu Server werden keine GPIO Libraries automatisch mitgeliefert, folglich verwenden wir die modernere Architektur</a:t>
+            </a:r>
+          </a:p>
+          <a:p>
+            <a:pPr marL="342900" indent="-342900">
+              <a:buFont typeface="Arial" panose="020B0604020202020204" pitchFamily="34" charset="0"/>
+              <a:buChar char="•"/>
+            </a:pPr>
+            <a:r>
+              <a:rPr lang="de-DE" sz="2260" dirty="0"/>
+              <a:t>Umstellung veralteter GPIO Bibliothek zu </a:t>
+            </a:r>
+            <a:r>
+              <a:rPr lang="de-DE" sz="2260" dirty="0" err="1"/>
+              <a:t>LibGPIOD</a:t>
+            </a:r>
+            <a:endParaRPr lang="de-DE" sz="2260" dirty="0"/>
+          </a:p>
+          <a:p>
+            <a:pPr marL="342900" indent="-342900">
+              <a:buFont typeface="Arial" panose="020B0604020202020204" pitchFamily="34" charset="0"/>
+              <a:buChar char="•"/>
+            </a:pPr>
+            <a:r>
+              <a:rPr lang="de-DE" sz="2260" dirty="0"/>
+              <a:t>Neue Stromverbindungen verhindern Kabelbruch der Batterieverbindung</a:t>
+            </a:r>
+          </a:p>
+        </p:txBody>
+      </p:sp>
+      <p:sp>
+        <p:nvSpPr>
+          <p:cNvPr id="14" name="Textfeld 13">
+            <a:extLst>
+              <a:ext uri="{FF2B5EF4-FFF2-40B4-BE49-F238E27FC236}">
+                <a16:creationId xmlns:a16="http://schemas.microsoft.com/office/drawing/2014/main" id="{D446D99F-A928-1DCE-3F05-A0732C36BB09}"/>
+              </a:ext>
+            </a:extLst>
+          </p:cNvPr>
+          <p:cNvSpPr txBox="1"/>
+          <p:nvPr/>
+        </p:nvSpPr>
+        <p:spPr>
+          <a:xfrm>
+            <a:off x="10420247" y="10216527"/>
+            <a:ext cx="10773506" cy="1483483"/>
+          </a:xfrm>
+          <a:prstGeom prst="rect">
+            <a:avLst/>
+          </a:prstGeom>
+          <a:noFill/>
+        </p:spPr>
+        <p:txBody>
+          <a:bodyPr wrap="square">
+            <a:spAutoFit/>
+          </a:bodyPr>
+          <a:lstStyle/>
+          <a:p>
+            <a:r>
+              <a:rPr lang="de-DE" sz="2260" b="1" dirty="0"/>
+              <a:t>Ergebnis</a:t>
+            </a:r>
+          </a:p>
+          <a:p>
+            <a:pPr marL="342900" indent="-342900">
+              <a:buFont typeface="Arial" panose="020B0604020202020204" pitchFamily="34" charset="0"/>
+              <a:buChar char="•"/>
+            </a:pPr>
+            <a:r>
+              <a:rPr lang="de-DE" sz="2260" dirty="0"/>
+              <a:t>Deutlich mehr verfügbare Rechen- und Speicherressourcen</a:t>
+            </a:r>
+          </a:p>
+          <a:p>
+            <a:pPr marL="342900" indent="-342900">
+              <a:buFont typeface="Arial" panose="020B0604020202020204" pitchFamily="34" charset="0"/>
+              <a:buChar char="•"/>
+            </a:pPr>
+            <a:r>
+              <a:rPr lang="de-DE" sz="2260" dirty="0"/>
+              <a:t>Stabiler Betrieb</a:t>
+            </a:r>
+          </a:p>
+          <a:p>
+            <a:pPr marL="342900" indent="-342900">
+              <a:buFont typeface="Arial" panose="020B0604020202020204" pitchFamily="34" charset="0"/>
+              <a:buChar char="•"/>
+            </a:pPr>
+            <a:r>
+              <a:rPr lang="de-DE" sz="2260" dirty="0"/>
+              <a:t>Reproduzierbares Setup</a:t>
+            </a:r>
+          </a:p>
+        </p:txBody>
+      </p:sp>
+      <p:sp>
+        <p:nvSpPr>
+          <p:cNvPr id="15" name="Textfeld 14">
+            <a:extLst>
+              <a:ext uri="{FF2B5EF4-FFF2-40B4-BE49-F238E27FC236}">
+                <a16:creationId xmlns:a16="http://schemas.microsoft.com/office/drawing/2014/main" id="{086ED35E-4918-5F3D-1734-61774D35E7C5}"/>
+              </a:ext>
+            </a:extLst>
+          </p:cNvPr>
+          <p:cNvSpPr txBox="1"/>
+          <p:nvPr/>
+        </p:nvSpPr>
+        <p:spPr>
+          <a:xfrm>
+            <a:off x="10420247" y="7953250"/>
+            <a:ext cx="10773506" cy="1831271"/>
+          </a:xfrm>
+          <a:prstGeom prst="rect">
+            <a:avLst/>
+          </a:prstGeom>
+          <a:noFill/>
+        </p:spPr>
+        <p:txBody>
+          <a:bodyPr wrap="square">
+            <a:spAutoFit/>
+          </a:bodyPr>
+          <a:lstStyle/>
+          <a:p>
+            <a:r>
+              <a:rPr lang="de-DE" sz="2260" b="1" dirty="0" err="1"/>
+              <a:t>Deployment</a:t>
+            </a:r>
+            <a:r>
+              <a:rPr lang="de-DE" sz="2260" b="1" dirty="0"/>
+              <a:t> &amp; Automatisierung</a:t>
+            </a:r>
+          </a:p>
+          <a:p>
+            <a:pPr marL="342900" indent="-342900">
+              <a:buFont typeface="Arial" panose="020B0604020202020204" pitchFamily="34" charset="0"/>
+              <a:buChar char="•"/>
+            </a:pPr>
+            <a:r>
+              <a:rPr lang="de-DE" sz="2260" dirty="0"/>
+              <a:t>Bash-Skript für OS-Setup</a:t>
+            </a:r>
+          </a:p>
+          <a:p>
+            <a:pPr marL="342900" indent="-342900">
+              <a:buFont typeface="Arial" panose="020B0604020202020204" pitchFamily="34" charset="0"/>
+              <a:buChar char="•"/>
+            </a:pPr>
+            <a:r>
+              <a:rPr lang="de-DE" sz="2260" dirty="0"/>
+              <a:t>Ready-</a:t>
+            </a:r>
+            <a:r>
+              <a:rPr lang="de-DE" sz="2260" dirty="0" err="1"/>
+              <a:t>to</a:t>
+            </a:r>
+            <a:r>
+              <a:rPr lang="de-DE" sz="2260" dirty="0"/>
+              <a:t>-run Docker Image ohne </a:t>
+            </a:r>
+            <a:r>
+              <a:rPr lang="de-DE" sz="2260" dirty="0" err="1"/>
+              <a:t>Install</a:t>
+            </a:r>
+            <a:r>
+              <a:rPr lang="de-DE" sz="2260" dirty="0"/>
+              <a:t>-Befehle innerhalb </a:t>
+            </a:r>
+          </a:p>
+          <a:p>
+            <a:pPr marL="342900" indent="-342900">
+              <a:buFont typeface="Arial" panose="020B0604020202020204" pitchFamily="34" charset="0"/>
+              <a:buChar char="•"/>
+            </a:pPr>
+            <a:r>
+              <a:rPr lang="de-DE" sz="2260" dirty="0"/>
+              <a:t>Nach RPI-Boot ist das komplette System Einsatzbereit ohne Menschliche Interaktion</a:t>
+            </a:r>
+          </a:p>
+        </p:txBody>
+      </p:sp>
+      <p:sp>
+        <p:nvSpPr>
+          <p:cNvPr id="18" name="Textfeld 17">
+            <a:extLst>
+              <a:ext uri="{FF2B5EF4-FFF2-40B4-BE49-F238E27FC236}">
+                <a16:creationId xmlns:a16="http://schemas.microsoft.com/office/drawing/2014/main" id="{399B1778-5EBA-834F-8155-C2EED25CEF9D}"/>
+              </a:ext>
+            </a:extLst>
+          </p:cNvPr>
+          <p:cNvSpPr txBox="1"/>
+          <p:nvPr/>
+        </p:nvSpPr>
+        <p:spPr>
+          <a:xfrm>
+            <a:off x="10420247" y="1928451"/>
+            <a:ext cx="9614367" cy="1048877"/>
+          </a:xfrm>
+          <a:prstGeom prst="rect">
+            <a:avLst/>
+          </a:prstGeom>
+          <a:noFill/>
+        </p:spPr>
+        <p:txBody>
+          <a:bodyPr wrap="square" rtlCol="0">
+            <a:spAutoFit/>
+          </a:bodyPr>
+          <a:lstStyle/>
+          <a:p>
+            <a:r>
+              <a:rPr lang="de-DE" sz="3108" dirty="0"/>
+              <a:t>Verbesserte Systemarchitektur, Reproduzierbares Setup </a:t>
+            </a:r>
+            <a:r>
+              <a:rPr lang="de-DE" sz="3108"/>
+              <a:t>und </a:t>
+            </a:r>
+            <a:r>
+              <a:rPr lang="de-DE" sz="3108" dirty="0"/>
+              <a:t>M</a:t>
+            </a:r>
+            <a:r>
+              <a:rPr lang="de-DE" sz="3108"/>
+              <a:t>odernisierung </a:t>
+            </a:r>
+            <a:r>
+              <a:rPr lang="de-DE" sz="3108" dirty="0"/>
+              <a:t>der Technik</a:t>
+            </a:r>
+          </a:p>
+        </p:txBody>
+      </p:sp>
+      <p:cxnSp>
+        <p:nvCxnSpPr>
+          <p:cNvPr id="37" name="Gerader Verbinder 36">
+            <a:extLst>
+              <a:ext uri="{FF2B5EF4-FFF2-40B4-BE49-F238E27FC236}">
+                <a16:creationId xmlns:a16="http://schemas.microsoft.com/office/drawing/2014/main" id="{100A4BCF-A974-0CAC-4282-9C026C72E2E4}"/>
+              </a:ext>
+            </a:extLst>
+          </p:cNvPr>
+          <p:cNvCxnSpPr>
+            <a:cxnSpLocks/>
+          </p:cNvCxnSpPr>
+          <p:nvPr/>
+        </p:nvCxnSpPr>
+        <p:spPr>
+          <a:xfrm>
+            <a:off x="10183153" y="1780023"/>
+            <a:ext cx="11200472" cy="0"/>
+          </a:xfrm>
+          <a:prstGeom prst="line">
+            <a:avLst/>
+          </a:prstGeom>
+        </p:spPr>
+        <p:style>
+          <a:lnRef idx="2">
+            <a:schemeClr val="accent1"/>
+          </a:lnRef>
+          <a:fillRef idx="0">
+            <a:schemeClr val="accent1"/>
+          </a:fillRef>
+          <a:effectRef idx="1">
+            <a:schemeClr val="accent1"/>
+          </a:effectRef>
+          <a:fontRef idx="minor">
+            <a:schemeClr val="tx1"/>
+          </a:fontRef>
+        </p:style>
+      </p:cxnSp>
+      <p:cxnSp>
+        <p:nvCxnSpPr>
+          <p:cNvPr id="39" name="Gerader Verbinder 38">
+            <a:extLst>
+              <a:ext uri="{FF2B5EF4-FFF2-40B4-BE49-F238E27FC236}">
+                <a16:creationId xmlns:a16="http://schemas.microsoft.com/office/drawing/2014/main" id="{A7AEA1AD-5F64-81A6-0778-181BA7081140}"/>
+              </a:ext>
+            </a:extLst>
+          </p:cNvPr>
+          <p:cNvCxnSpPr>
+            <a:cxnSpLocks/>
+          </p:cNvCxnSpPr>
+          <p:nvPr/>
+        </p:nvCxnSpPr>
+        <p:spPr>
+          <a:xfrm>
+            <a:off x="10155514" y="12052056"/>
+            <a:ext cx="11200472" cy="0"/>
+          </a:xfrm>
+          <a:prstGeom prst="line">
+            <a:avLst/>
+          </a:prstGeom>
+        </p:spPr>
+        <p:style>
+          <a:lnRef idx="2">
+            <a:schemeClr val="accent1"/>
+          </a:lnRef>
+          <a:fillRef idx="0">
+            <a:schemeClr val="accent1"/>
+          </a:fillRef>
+          <a:effectRef idx="1">
+            <a:schemeClr val="accent1"/>
+          </a:effectRef>
+          <a:fontRef idx="minor">
+            <a:schemeClr val="tx1"/>
+          </a:fontRef>
+        </p:style>
+      </p:cxnSp>
     </p:spTree>
     <p:extLst>
       <p:ext uri="{BB962C8B-B14F-4D97-AF65-F5344CB8AC3E}">

</xml_diff>

<commit_message>
hinzufügen von handy Steuerung auf Plakat
</commit_message>
<xml_diff>
--- a/doc/Technikforum/Plakat_Forum.pptx
+++ b/doc/Technikforum/Plakat_Forum.pptx
@@ -118,7 +118,7 @@
 <file path=ppt/revisionInfo.xml><?xml version="1.0" encoding="utf-8"?>
 <p1510:revInfo xmlns:a="http://schemas.openxmlformats.org/drawingml/2006/main" xmlns:r="http://schemas.openxmlformats.org/officeDocument/2006/relationships" xmlns:p1510="http://schemas.microsoft.com/office/powerpoint/2015/10/main">
   <p1510:revLst>
-    <p1510:client id="{974C6F5C-8394-499A-B74A-2887A4D69D20}" v="19" dt="2026-05-20T13:04:01.743"/>
+    <p1510:client id="{974C6F5C-8394-499A-B74A-2887A4D69D20}" v="27" dt="2026-05-20T13:23:06.125"/>
   </p1510:revLst>
 </p1510:revInfo>
 </file>
@@ -128,12 +128,12 @@
   <pc:docChgLst>
     <pc:chgData name="Maurer, Marius" userId="73e198c0-4891-41c9-a475-1c219e411f9f" providerId="ADAL" clId="{B2A80625-E86A-4CEB-9035-CBD35C99A22C}"/>
     <pc:docChg chg="undo redo custSel modSld">
-      <pc:chgData name="Maurer, Marius" userId="73e198c0-4891-41c9-a475-1c219e411f9f" providerId="ADAL" clId="{B2A80625-E86A-4CEB-9035-CBD35C99A22C}" dt="2026-05-20T13:06:02.175" v="1536" actId="313"/>
+      <pc:chgData name="Maurer, Marius" userId="73e198c0-4891-41c9-a475-1c219e411f9f" providerId="ADAL" clId="{B2A80625-E86A-4CEB-9035-CBD35C99A22C}" dt="2026-05-20T13:25:36.702" v="1941" actId="20577"/>
       <pc:docMkLst>
         <pc:docMk/>
       </pc:docMkLst>
       <pc:sldChg chg="addSp delSp modSp mod">
-        <pc:chgData name="Maurer, Marius" userId="73e198c0-4891-41c9-a475-1c219e411f9f" providerId="ADAL" clId="{B2A80625-E86A-4CEB-9035-CBD35C99A22C}" dt="2026-05-20T13:06:02.175" v="1536" actId="313"/>
+        <pc:chgData name="Maurer, Marius" userId="73e198c0-4891-41c9-a475-1c219e411f9f" providerId="ADAL" clId="{B2A80625-E86A-4CEB-9035-CBD35C99A22C}" dt="2026-05-20T13:25:36.702" v="1941" actId="20577"/>
         <pc:sldMkLst>
           <pc:docMk/>
           <pc:sldMk cId="332124325" sldId="256"/>
@@ -179,7 +179,7 @@
           </ac:spMkLst>
         </pc:spChg>
         <pc:spChg chg="mod">
-          <ac:chgData name="Maurer, Marius" userId="73e198c0-4891-41c9-a475-1c219e411f9f" providerId="ADAL" clId="{B2A80625-E86A-4CEB-9035-CBD35C99A22C}" dt="2026-05-20T12:57:14.089" v="1058" actId="1035"/>
+          <ac:chgData name="Maurer, Marius" userId="73e198c0-4891-41c9-a475-1c219e411f9f" providerId="ADAL" clId="{B2A80625-E86A-4CEB-9035-CBD35C99A22C}" dt="2026-05-20T13:22:02.505" v="1603" actId="1036"/>
           <ac:spMkLst>
             <pc:docMk/>
             <pc:sldMk cId="332124325" sldId="256"/>
@@ -195,7 +195,7 @@
           </ac:spMkLst>
         </pc:spChg>
         <pc:spChg chg="add mod">
-          <ac:chgData name="Maurer, Marius" userId="73e198c0-4891-41c9-a475-1c219e411f9f" providerId="ADAL" clId="{B2A80625-E86A-4CEB-9035-CBD35C99A22C}" dt="2026-05-20T12:56:14.062" v="975" actId="1035"/>
+          <ac:chgData name="Maurer, Marius" userId="73e198c0-4891-41c9-a475-1c219e411f9f" providerId="ADAL" clId="{B2A80625-E86A-4CEB-9035-CBD35C99A22C}" dt="2026-05-20T13:18:33.148" v="1551" actId="6549"/>
           <ac:spMkLst>
             <pc:docMk/>
             <pc:sldMk cId="332124325" sldId="256"/>
@@ -203,7 +203,7 @@
           </ac:spMkLst>
         </pc:spChg>
         <pc:spChg chg="mod">
-          <ac:chgData name="Maurer, Marius" userId="73e198c0-4891-41c9-a475-1c219e411f9f" providerId="ADAL" clId="{B2A80625-E86A-4CEB-9035-CBD35C99A22C}" dt="2026-05-20T12:57:14.089" v="1058" actId="1035"/>
+          <ac:chgData name="Maurer, Marius" userId="73e198c0-4891-41c9-a475-1c219e411f9f" providerId="ADAL" clId="{B2A80625-E86A-4CEB-9035-CBD35C99A22C}" dt="2026-05-20T13:22:02.505" v="1603" actId="1036"/>
           <ac:spMkLst>
             <pc:docMk/>
             <pc:sldMk cId="332124325" sldId="256"/>
@@ -211,7 +211,7 @@
           </ac:spMkLst>
         </pc:spChg>
         <pc:spChg chg="mod">
-          <ac:chgData name="Maurer, Marius" userId="73e198c0-4891-41c9-a475-1c219e411f9f" providerId="ADAL" clId="{B2A80625-E86A-4CEB-9035-CBD35C99A22C}" dt="2026-05-20T12:57:14.089" v="1058" actId="1035"/>
+          <ac:chgData name="Maurer, Marius" userId="73e198c0-4891-41c9-a475-1c219e411f9f" providerId="ADAL" clId="{B2A80625-E86A-4CEB-9035-CBD35C99A22C}" dt="2026-05-20T13:22:02.505" v="1603" actId="1036"/>
           <ac:spMkLst>
             <pc:docMk/>
             <pc:sldMk cId="332124325" sldId="256"/>
@@ -219,7 +219,7 @@
           </ac:spMkLst>
         </pc:spChg>
         <pc:spChg chg="mod">
-          <ac:chgData name="Maurer, Marius" userId="73e198c0-4891-41c9-a475-1c219e411f9f" providerId="ADAL" clId="{B2A80625-E86A-4CEB-9035-CBD35C99A22C}" dt="2026-05-20T12:57:14.089" v="1058" actId="1035"/>
+          <ac:chgData name="Maurer, Marius" userId="73e198c0-4891-41c9-a475-1c219e411f9f" providerId="ADAL" clId="{B2A80625-E86A-4CEB-9035-CBD35C99A22C}" dt="2026-05-20T13:22:02.505" v="1603" actId="1036"/>
           <ac:spMkLst>
             <pc:docMk/>
             <pc:sldMk cId="332124325" sldId="256"/>
@@ -227,7 +227,7 @@
           </ac:spMkLst>
         </pc:spChg>
         <pc:spChg chg="mod">
-          <ac:chgData name="Maurer, Marius" userId="73e198c0-4891-41c9-a475-1c219e411f9f" providerId="ADAL" clId="{B2A80625-E86A-4CEB-9035-CBD35C99A22C}" dt="2026-05-20T12:57:14.089" v="1058" actId="1035"/>
+          <ac:chgData name="Maurer, Marius" userId="73e198c0-4891-41c9-a475-1c219e411f9f" providerId="ADAL" clId="{B2A80625-E86A-4CEB-9035-CBD35C99A22C}" dt="2026-05-20T13:22:02.505" v="1603" actId="1036"/>
           <ac:spMkLst>
             <pc:docMk/>
             <pc:sldMk cId="332124325" sldId="256"/>
@@ -251,7 +251,7 @@
           </ac:spMkLst>
         </pc:spChg>
         <pc:spChg chg="add mod">
-          <ac:chgData name="Maurer, Marius" userId="73e198c0-4891-41c9-a475-1c219e411f9f" providerId="ADAL" clId="{B2A80625-E86A-4CEB-9035-CBD35C99A22C}" dt="2026-05-20T12:59:13.775" v="1319" actId="255"/>
+          <ac:chgData name="Maurer, Marius" userId="73e198c0-4891-41c9-a475-1c219e411f9f" providerId="ADAL" clId="{B2A80625-E86A-4CEB-9035-CBD35C99A22C}" dt="2026-05-20T13:22:02.505" v="1603" actId="1036"/>
           <ac:spMkLst>
             <pc:docMk/>
             <pc:sldMk cId="332124325" sldId="256"/>
@@ -259,11 +259,43 @@
           </ac:spMkLst>
         </pc:spChg>
         <pc:spChg chg="add mod">
-          <ac:chgData name="Maurer, Marius" userId="73e198c0-4891-41c9-a475-1c219e411f9f" providerId="ADAL" clId="{B2A80625-E86A-4CEB-9035-CBD35C99A22C}" dt="2026-05-20T13:06:02.175" v="1536" actId="313"/>
+          <ac:chgData name="Maurer, Marius" userId="73e198c0-4891-41c9-a475-1c219e411f9f" providerId="ADAL" clId="{B2A80625-E86A-4CEB-9035-CBD35C99A22C}" dt="2026-05-20T13:22:02.505" v="1603" actId="1036"/>
           <ac:spMkLst>
             <pc:docMk/>
             <pc:sldMk cId="332124325" sldId="256"/>
             <ac:spMk id="33" creationId="{22CAC9EC-4426-86E6-AA5F-1B3058572100}"/>
+          </ac:spMkLst>
+        </pc:spChg>
+        <pc:spChg chg="add">
+          <ac:chgData name="Maurer, Marius" userId="73e198c0-4891-41c9-a475-1c219e411f9f" providerId="ADAL" clId="{B2A80625-E86A-4CEB-9035-CBD35C99A22C}" dt="2026-05-20T13:17:52.062" v="1540"/>
+          <ac:spMkLst>
+            <pc:docMk/>
+            <pc:sldMk cId="332124325" sldId="256"/>
+            <ac:spMk id="36" creationId="{3F3D7512-1DB5-587F-B68E-6B34C6E2D0AA}"/>
+          </ac:spMkLst>
+        </pc:spChg>
+        <pc:spChg chg="add">
+          <ac:chgData name="Maurer, Marius" userId="73e198c0-4891-41c9-a475-1c219e411f9f" providerId="ADAL" clId="{B2A80625-E86A-4CEB-9035-CBD35C99A22C}" dt="2026-05-20T13:19:55.523" v="1570"/>
+          <ac:spMkLst>
+            <pc:docMk/>
+            <pc:sldMk cId="332124325" sldId="256"/>
+            <ac:spMk id="40" creationId="{36373DC0-5FC4-445A-D64B-B5C3F5425CDE}"/>
+          </ac:spMkLst>
+        </pc:spChg>
+        <pc:spChg chg="add mod">
+          <ac:chgData name="Maurer, Marius" userId="73e198c0-4891-41c9-a475-1c219e411f9f" providerId="ADAL" clId="{B2A80625-E86A-4CEB-9035-CBD35C99A22C}" dt="2026-05-20T13:22:59.254" v="1628" actId="20577"/>
+          <ac:spMkLst>
+            <pc:docMk/>
+            <pc:sldMk cId="332124325" sldId="256"/>
+            <ac:spMk id="42" creationId="{626029D7-CB6C-1AD8-FCAB-27DAB17BC0B2}"/>
+          </ac:spMkLst>
+        </pc:spChg>
+        <pc:spChg chg="add mod">
+          <ac:chgData name="Maurer, Marius" userId="73e198c0-4891-41c9-a475-1c219e411f9f" providerId="ADAL" clId="{B2A80625-E86A-4CEB-9035-CBD35C99A22C}" dt="2026-05-20T13:25:36.702" v="1941" actId="20577"/>
+          <ac:spMkLst>
+            <pc:docMk/>
+            <pc:sldMk cId="332124325" sldId="256"/>
+            <ac:spMk id="43" creationId="{5BF47525-5F99-2C58-B7B4-7694730A563B}"/>
           </ac:spMkLst>
         </pc:spChg>
         <pc:spChg chg="mod">
@@ -291,7 +323,7 @@
           </ac:spMkLst>
         </pc:spChg>
         <pc:picChg chg="add mod ord modCrop">
-          <ac:chgData name="Maurer, Marius" userId="73e198c0-4891-41c9-a475-1c219e411f9f" providerId="ADAL" clId="{B2A80625-E86A-4CEB-9035-CBD35C99A22C}" dt="2026-05-20T12:56:57.431" v="1023" actId="1076"/>
+          <ac:chgData name="Maurer, Marius" userId="73e198c0-4891-41c9-a475-1c219e411f9f" providerId="ADAL" clId="{B2A80625-E86A-4CEB-9035-CBD35C99A22C}" dt="2026-05-20T13:18:52.445" v="1566" actId="1037"/>
           <ac:picMkLst>
             <pc:docMk/>
             <pc:sldMk cId="332124325" sldId="256"/>
@@ -299,7 +331,7 @@
           </ac:picMkLst>
         </pc:picChg>
         <pc:picChg chg="mod">
-          <ac:chgData name="Maurer, Marius" userId="73e198c0-4891-41c9-a475-1c219e411f9f" providerId="ADAL" clId="{B2A80625-E86A-4CEB-9035-CBD35C99A22C}" dt="2026-05-20T12:57:14.089" v="1058" actId="1035"/>
+          <ac:chgData name="Maurer, Marius" userId="73e198c0-4891-41c9-a475-1c219e411f9f" providerId="ADAL" clId="{B2A80625-E86A-4CEB-9035-CBD35C99A22C}" dt="2026-05-20T13:22:02.505" v="1603" actId="1036"/>
           <ac:picMkLst>
             <pc:docMk/>
             <pc:sldMk cId="332124325" sldId="256"/>
@@ -307,7 +339,7 @@
           </ac:picMkLst>
         </pc:picChg>
         <pc:picChg chg="mod">
-          <ac:chgData name="Maurer, Marius" userId="73e198c0-4891-41c9-a475-1c219e411f9f" providerId="ADAL" clId="{B2A80625-E86A-4CEB-9035-CBD35C99A22C}" dt="2026-05-20T12:57:14.089" v="1058" actId="1035"/>
+          <ac:chgData name="Maurer, Marius" userId="73e198c0-4891-41c9-a475-1c219e411f9f" providerId="ADAL" clId="{B2A80625-E86A-4CEB-9035-CBD35C99A22C}" dt="2026-05-20T13:22:02.505" v="1603" actId="1036"/>
           <ac:picMkLst>
             <pc:docMk/>
             <pc:sldMk cId="332124325" sldId="256"/>
@@ -315,7 +347,7 @@
           </ac:picMkLst>
         </pc:picChg>
         <pc:picChg chg="mod">
-          <ac:chgData name="Maurer, Marius" userId="73e198c0-4891-41c9-a475-1c219e411f9f" providerId="ADAL" clId="{B2A80625-E86A-4CEB-9035-CBD35C99A22C}" dt="2026-05-20T12:57:14.089" v="1058" actId="1035"/>
+          <ac:chgData name="Maurer, Marius" userId="73e198c0-4891-41c9-a475-1c219e411f9f" providerId="ADAL" clId="{B2A80625-E86A-4CEB-9035-CBD35C99A22C}" dt="2026-05-20T13:22:02.505" v="1603" actId="1036"/>
           <ac:picMkLst>
             <pc:docMk/>
             <pc:sldMk cId="332124325" sldId="256"/>
@@ -336,6 +368,22 @@
             <pc:docMk/>
             <pc:sldMk cId="332124325" sldId="256"/>
             <ac:picMk id="27" creationId="{822573AC-178E-6D03-8D34-8E9D4CFAE777}"/>
+          </ac:picMkLst>
+        </pc:picChg>
+        <pc:picChg chg="add mod">
+          <ac:chgData name="Maurer, Marius" userId="73e198c0-4891-41c9-a475-1c219e411f9f" providerId="ADAL" clId="{B2A80625-E86A-4CEB-9035-CBD35C99A22C}" dt="2026-05-20T13:25:24.095" v="1938" actId="1076"/>
+          <ac:picMkLst>
+            <pc:docMk/>
+            <pc:sldMk cId="332124325" sldId="256"/>
+            <ac:picMk id="38" creationId="{74CFA65C-03A9-0830-55FE-D9225A14B4F7}"/>
+          </ac:picMkLst>
+        </pc:picChg>
+        <pc:picChg chg="add mod">
+          <ac:chgData name="Maurer, Marius" userId="73e198c0-4891-41c9-a475-1c219e411f9f" providerId="ADAL" clId="{B2A80625-E86A-4CEB-9035-CBD35C99A22C}" dt="2026-05-20T13:25:11.451" v="1929" actId="1038"/>
+          <ac:picMkLst>
+            <pc:docMk/>
+            <pc:sldMk cId="332124325" sldId="256"/>
+            <ac:picMk id="41" creationId="{31E99089-7FD7-4D0D-A7A2-F044052F2130}"/>
           </ac:picMkLst>
         </pc:picChg>
         <pc:picChg chg="mod">
@@ -3697,8 +3745,8 @@
         </p:blipFill>
         <p:spPr>
           <a:xfrm>
-            <a:off x="11598330" y="12118931"/>
-            <a:ext cx="8370118" cy="5191711"/>
+            <a:off x="3863370" y="6613042"/>
+            <a:ext cx="6655210" cy="4128010"/>
           </a:xfrm>
           <a:prstGeom prst="rect">
             <a:avLst/>
@@ -3734,7 +3782,7 @@
         </p:blipFill>
         <p:spPr>
           <a:xfrm>
-            <a:off x="10420248" y="21107552"/>
+            <a:off x="10420248" y="21691208"/>
             <a:ext cx="3476096" cy="2178000"/>
           </a:xfrm>
           <a:prstGeom prst="rect">
@@ -3771,7 +3819,7 @@
         </p:blipFill>
         <p:spPr>
           <a:xfrm>
-            <a:off x="10420247" y="23375087"/>
+            <a:off x="10420247" y="23958743"/>
             <a:ext cx="3476097" cy="2178000"/>
           </a:xfrm>
           <a:prstGeom prst="rect">
@@ -3808,7 +3856,7 @@
         </p:blipFill>
         <p:spPr>
           <a:xfrm>
-            <a:off x="10420246" y="18489759"/>
+            <a:off x="10420246" y="19073415"/>
             <a:ext cx="3476098" cy="2527200"/>
           </a:xfrm>
           <a:prstGeom prst="rect">
@@ -3904,8 +3952,8 @@
         </p:nvSpPr>
         <p:spPr>
           <a:xfrm>
-            <a:off x="10340109" y="17350289"/>
-            <a:ext cx="9614367" cy="1048877"/>
+            <a:off x="10340109" y="17933945"/>
+            <a:ext cx="10853644" cy="1048877"/>
           </a:xfrm>
           <a:prstGeom prst="rect">
             <a:avLst/>
@@ -3939,7 +3987,7 @@
         </p:nvSpPr>
         <p:spPr>
           <a:xfrm>
-            <a:off x="14001072" y="18490113"/>
+            <a:off x="14001072" y="19073769"/>
             <a:ext cx="5953404" cy="2526846"/>
           </a:xfrm>
           <a:prstGeom prst="rect">
@@ -4004,7 +4052,7 @@
         </p:nvSpPr>
         <p:spPr>
           <a:xfrm>
-            <a:off x="14001072" y="21106494"/>
+            <a:off x="14001072" y="21690150"/>
             <a:ext cx="5953404" cy="2179058"/>
           </a:xfrm>
           <a:prstGeom prst="rect">
@@ -4069,7 +4117,7 @@
         </p:nvSpPr>
         <p:spPr>
           <a:xfrm>
-            <a:off x="14001072" y="23375087"/>
+            <a:off x="14001072" y="23958743"/>
             <a:ext cx="6162860" cy="2179058"/>
           </a:xfrm>
           <a:prstGeom prst="rect">
@@ -4134,7 +4182,7 @@
         </p:nvSpPr>
         <p:spPr>
           <a:xfrm>
-            <a:off x="14001072" y="25643680"/>
+            <a:off x="14001072" y="26227336"/>
             <a:ext cx="6162860" cy="1831271"/>
           </a:xfrm>
           <a:prstGeom prst="rect">
@@ -4220,7 +4268,7 @@
         </p:blipFill>
         <p:spPr>
           <a:xfrm>
-            <a:off x="10340109" y="25642622"/>
+            <a:off x="10340109" y="26226278"/>
             <a:ext cx="3556235" cy="1831271"/>
           </a:xfrm>
           <a:prstGeom prst="rect">
@@ -5095,7 +5143,7 @@
         </p:nvCxnSpPr>
         <p:spPr>
           <a:xfrm>
-            <a:off x="10184344" y="17082485"/>
+            <a:off x="10184344" y="17666141"/>
             <a:ext cx="11200472" cy="0"/>
           </a:xfrm>
           <a:prstGeom prst="line">
@@ -5282,7 +5330,7 @@
         <p:spPr>
           <a:xfrm>
             <a:off x="214461" y="5766423"/>
-            <a:ext cx="9756186" cy="6352508"/>
+            <a:ext cx="9756186" cy="6700296"/>
           </a:xfrm>
           <a:prstGeom prst="rect">
             <a:avLst/>
@@ -5385,7 +5433,14 @@
             </a:pPr>
             <a:r>
               <a:rPr lang="de-DE" sz="2260" dirty="0"/>
-              <a:t>Frontalneigung um 7° wegen zu schwerem Vorbau</a:t>
+              <a:t>Frontalneigung um 7° wegen</a:t>
+            </a:r>
+            <a:br>
+              <a:rPr lang="de-DE" sz="2260" dirty="0"/>
+            </a:br>
+            <a:r>
+              <a:rPr lang="de-DE" sz="2260" dirty="0"/>
+              <a:t>zu schwerem Vorbau</a:t>
             </a:r>
           </a:p>
           <a:p>
@@ -5471,7 +5526,7 @@
         </p:nvSpPr>
         <p:spPr>
           <a:xfrm>
-            <a:off x="10420246" y="27660600"/>
+            <a:off x="10420246" y="28244256"/>
             <a:ext cx="10797545" cy="1135696"/>
           </a:xfrm>
           <a:prstGeom prst="rect">
@@ -5508,7 +5563,7 @@
         </p:nvCxnSpPr>
         <p:spPr>
           <a:xfrm>
-            <a:off x="10217895" y="28802045"/>
+            <a:off x="10217895" y="29385701"/>
             <a:ext cx="11200472" cy="0"/>
           </a:xfrm>
           <a:prstGeom prst="line">
@@ -5544,7 +5599,7 @@
         </p:nvSpPr>
         <p:spPr>
           <a:xfrm>
-            <a:off x="10340109" y="28956043"/>
+            <a:off x="10340109" y="29539699"/>
             <a:ext cx="10797545" cy="787908"/>
           </a:xfrm>
           <a:prstGeom prst="rect">
@@ -5561,6 +5616,136 @@
             <a:r>
               <a:rPr lang="de-DE" sz="2260" dirty="0"/>
               <a:t>Studiengang Informatik in den Fachbereichen Informationstechnik und Künstliche Intelligenz</a:t>
+            </a:r>
+          </a:p>
+        </p:txBody>
+      </p:sp>
+      <p:pic>
+        <p:nvPicPr>
+          <p:cNvPr id="38" name="Grafik 37">
+            <a:extLst>
+              <a:ext uri="{FF2B5EF4-FFF2-40B4-BE49-F238E27FC236}">
+                <a16:creationId xmlns:a16="http://schemas.microsoft.com/office/drawing/2014/main" id="{74CFA65C-03A9-0830-55FE-D9225A14B4F7}"/>
+              </a:ext>
+            </a:extLst>
+          </p:cNvPr>
+          <p:cNvPicPr>
+            <a:picLocks noChangeAspect="1"/>
+          </p:cNvPicPr>
+          <p:nvPr/>
+        </p:nvPicPr>
+        <p:blipFill>
+          <a:blip r:embed="rId9"/>
+          <a:stretch>
+            <a:fillRect/>
+          </a:stretch>
+        </p:blipFill>
+        <p:spPr>
+          <a:xfrm>
+            <a:off x="10518580" y="14273939"/>
+            <a:ext cx="7158812" cy="3187909"/>
+          </a:xfrm>
+          <a:prstGeom prst="rect">
+            <a:avLst/>
+          </a:prstGeom>
+        </p:spPr>
+      </p:pic>
+      <p:pic>
+        <p:nvPicPr>
+          <p:cNvPr id="41" name="Grafik 40">
+            <a:extLst>
+              <a:ext uri="{FF2B5EF4-FFF2-40B4-BE49-F238E27FC236}">
+                <a16:creationId xmlns:a16="http://schemas.microsoft.com/office/drawing/2014/main" id="{31E99089-7FD7-4D0D-A7A2-F044052F2130}"/>
+              </a:ext>
+            </a:extLst>
+          </p:cNvPr>
+          <p:cNvPicPr>
+            <a:picLocks noChangeAspect="1"/>
+          </p:cNvPicPr>
+          <p:nvPr/>
+        </p:nvPicPr>
+        <p:blipFill>
+          <a:blip r:embed="rId10"/>
+          <a:stretch>
+            <a:fillRect/>
+          </a:stretch>
+        </p:blipFill>
+        <p:spPr>
+          <a:xfrm>
+            <a:off x="17789119" y="12194857"/>
+            <a:ext cx="3383430" cy="5285635"/>
+          </a:xfrm>
+          <a:prstGeom prst="rect">
+            <a:avLst/>
+          </a:prstGeom>
+        </p:spPr>
+      </p:pic>
+      <p:sp>
+        <p:nvSpPr>
+          <p:cNvPr id="42" name="Textfeld 41">
+            <a:extLst>
+              <a:ext uri="{FF2B5EF4-FFF2-40B4-BE49-F238E27FC236}">
+                <a16:creationId xmlns:a16="http://schemas.microsoft.com/office/drawing/2014/main" id="{626029D7-CB6C-1AD8-FCAB-27DAB17BC0B2}"/>
+              </a:ext>
+            </a:extLst>
+          </p:cNvPr>
+          <p:cNvSpPr txBox="1"/>
+          <p:nvPr/>
+        </p:nvSpPr>
+        <p:spPr>
+          <a:xfrm>
+            <a:off x="10420246" y="12194856"/>
+            <a:ext cx="7024351" cy="570926"/>
+          </a:xfrm>
+          <a:prstGeom prst="rect">
+            <a:avLst/>
+          </a:prstGeom>
+          <a:noFill/>
+        </p:spPr>
+        <p:txBody>
+          <a:bodyPr wrap="square" rtlCol="0">
+            <a:spAutoFit/>
+          </a:bodyPr>
+          <a:lstStyle/>
+          <a:p>
+            <a:r>
+              <a:rPr lang="de-DE" sz="3110" dirty="0"/>
+              <a:t>Bedienung per Handy</a:t>
+            </a:r>
+          </a:p>
+        </p:txBody>
+      </p:sp>
+      <p:sp>
+        <p:nvSpPr>
+          <p:cNvPr id="43" name="Textfeld 42">
+            <a:extLst>
+              <a:ext uri="{FF2B5EF4-FFF2-40B4-BE49-F238E27FC236}">
+                <a16:creationId xmlns:a16="http://schemas.microsoft.com/office/drawing/2014/main" id="{5BF47525-5F99-2C58-B7B4-7694730A563B}"/>
+              </a:ext>
+            </a:extLst>
+          </p:cNvPr>
+          <p:cNvSpPr txBox="1"/>
+          <p:nvPr/>
+        </p:nvSpPr>
+        <p:spPr>
+          <a:xfrm>
+            <a:off x="10442693" y="12771813"/>
+            <a:ext cx="7432731" cy="1483483"/>
+          </a:xfrm>
+          <a:prstGeom prst="rect">
+            <a:avLst/>
+          </a:prstGeom>
+          <a:noFill/>
+        </p:spPr>
+        <p:txBody>
+          <a:bodyPr wrap="square" rtlCol="0">
+            <a:spAutoFit/>
+          </a:bodyPr>
+          <a:lstStyle/>
+          <a:p>
+            <a:r>
+              <a:rPr lang="de-DE" sz="2260" dirty="0"/>
+              <a:t>Die Steuerung funktioniert über eine übersichtlich strukturierte Handy App. Die Steuerung ist über Joysticks oder Neigung des Handys möglich. Für die Zukunft können mehrere Fahrzeuge in der App hinterlegt werden.</a:t>
             </a:r>
           </a:p>
         </p:txBody>

</xml_diff>